<commit_message>
sync: 2026-05-22 15:13:34 from Cowork
</commit_message>
<xml_diff>
--- a/outputs/Ledger_Rollup_Pitch_Deck.pptx
+++ b/outputs/Ledger_Rollup_Pitch_Deck.pptx
@@ -6821,7 +6821,7 @@
                 </a:solidFill>
                 <a:latin typeface="Calibri"/>
               </a:rPr>
-              <a:t>Sumer.io = product wedge.   Visma = roll-up playbook AND exit buyer.</a:t>
+              <a:t>Sumer (UK) = direct M&amp;A roll-up precedent.   Visma = AI-platform exit buyer.</a:t>
             </a:r>
           </a:p>
         </p:txBody>
@@ -6944,7 +6944,7 @@
                 </a:solidFill>
                 <a:latin typeface="Calibri"/>
               </a:rPr>
-              <a:t>SUMER.IO — the AI-accounting wedge</a:t>
+              <a:t>SUMER GROUP (UK) — the direct precedent</a:t>
             </a:r>
           </a:p>
         </p:txBody>
@@ -6979,7 +6979,7 @@
                 </a:solidFill>
                 <a:latin typeface="Calibri"/>
               </a:rPr>
-              <a:t>(Spain category reference — Holded, Anfix, Quipu, Sumer)</a:t>
+              <a:t>(Penta Capital-backed PE roll-up of UK accountancy practices)</a:t>
             </a:r>
           </a:p>
         </p:txBody>
@@ -6993,7 +6993,7 @@
         <p:spPr>
           <a:xfrm>
             <a:off x="548640" y="2423160"/>
-            <a:ext cx="1280160" cy="274320"/>
+            <a:ext cx="1463040" cy="274320"/>
           </a:xfrm>
           <a:prstGeom prst="rect">
             <a:avLst/>
@@ -7008,13 +7008,13 @@
           <a:p>
             <a:pPr algn="l"/>
             <a:r>
-              <a:rPr sz="1050" b="1" i="0">
+              <a:rPr sz="1000" b="1" i="0">
                 <a:solidFill>
                   <a:srgbClr val="1F3A5F"/>
                 </a:solidFill>
                 <a:latin typeface="Calibri"/>
               </a:rPr>
-              <a:t>Buyer:</a:t>
+              <a:t>Founded:</a:t>
             </a:r>
           </a:p>
         </p:txBody>
@@ -7027,8 +7027,8 @@
         </p:nvSpPr>
         <p:spPr>
           <a:xfrm>
-            <a:off x="1828800" y="2423160"/>
-            <a:ext cx="3566160" cy="274320"/>
+            <a:off x="2011680" y="2423160"/>
+            <a:ext cx="3383280" cy="274320"/>
           </a:xfrm>
           <a:prstGeom prst="rect">
             <a:avLst/>
@@ -7043,13 +7043,13 @@
           <a:p>
             <a:pPr algn="l"/>
             <a:r>
-              <a:rPr sz="1050" b="0" i="0">
+              <a:rPr sz="1000" b="0" i="0">
                 <a:solidFill>
                   <a:srgbClr val="101010"/>
                 </a:solidFill>
                 <a:latin typeface="Calibri"/>
               </a:rPr>
-              <a:t>Spanish self-employed and micro-SMB</a:t>
+              <a:t>2022 by Warren Mead (ex-KPMG UK COO) + 2 partners</a:t>
             </a:r>
           </a:p>
         </p:txBody>
@@ -7063,7 +7063,7 @@
         <p:spPr>
           <a:xfrm>
             <a:off x="548640" y="2715768"/>
-            <a:ext cx="1280160" cy="274320"/>
+            <a:ext cx="1463040" cy="274320"/>
           </a:xfrm>
           <a:prstGeom prst="rect">
             <a:avLst/>
@@ -7078,13 +7078,13 @@
           <a:p>
             <a:pPr algn="l"/>
             <a:r>
-              <a:rPr sz="1050" b="1" i="0">
+              <a:rPr sz="1000" b="1" i="0">
                 <a:solidFill>
                   <a:srgbClr val="1F3A5F"/>
                 </a:solidFill>
                 <a:latin typeface="Calibri"/>
               </a:rPr>
-              <a:t>Price point:</a:t>
+              <a:t>PE backer:</a:t>
             </a:r>
           </a:p>
         </p:txBody>
@@ -7097,8 +7097,8 @@
         </p:nvSpPr>
         <p:spPr>
           <a:xfrm>
-            <a:off x="1828800" y="2715768"/>
-            <a:ext cx="3566160" cy="274320"/>
+            <a:off x="2011680" y="2715768"/>
+            <a:ext cx="3383280" cy="274320"/>
           </a:xfrm>
           <a:prstGeom prst="rect">
             <a:avLst/>
@@ -7113,13 +7113,13 @@
           <a:p>
             <a:pPr algn="l"/>
             <a:r>
-              <a:rPr sz="1050" b="0" i="0">
+              <a:rPr sz="1000" b="0" i="0">
                 <a:solidFill>
                   <a:srgbClr val="101010"/>
                 </a:solidFill>
                 <a:latin typeface="Calibri"/>
               </a:rPr>
-              <a:t>€20–80 per seat per month</a:t>
+              <a:t>Penta Capital</a:t>
             </a:r>
           </a:p>
         </p:txBody>
@@ -7133,7 +7133,7 @@
         <p:spPr>
           <a:xfrm>
             <a:off x="548640" y="3008376"/>
-            <a:ext cx="1280160" cy="274320"/>
+            <a:ext cx="1463040" cy="274320"/>
           </a:xfrm>
           <a:prstGeom prst="rect">
             <a:avLst/>
@@ -7148,13 +7148,13 @@
           <a:p>
             <a:pPr algn="l"/>
             <a:r>
-              <a:rPr sz="1050" b="1" i="0">
+              <a:rPr sz="1000" b="1" i="0">
                 <a:solidFill>
                   <a:srgbClr val="1F3A5F"/>
                 </a:solidFill>
                 <a:latin typeface="Calibri"/>
               </a:rPr>
-              <a:t>Wedge:</a:t>
+              <a:t>Scale (Sept 2025):</a:t>
             </a:r>
           </a:p>
         </p:txBody>
@@ -7167,8 +7167,8 @@
         </p:nvSpPr>
         <p:spPr>
           <a:xfrm>
-            <a:off x="1828800" y="3008376"/>
-            <a:ext cx="3566160" cy="274320"/>
+            <a:off x="2011680" y="3008376"/>
+            <a:ext cx="3383280" cy="274320"/>
           </a:xfrm>
           <a:prstGeom prst="rect">
             <a:avLst/>
@@ -7183,13 +7183,13 @@
           <a:p>
             <a:pPr algn="l"/>
             <a:r>
-              <a:rPr sz="1050" b="0" i="0">
+              <a:rPr sz="1000" b="0" i="0">
                 <a:solidFill>
                   <a:srgbClr val="101010"/>
                 </a:solidFill>
                 <a:latin typeface="Calibri"/>
               </a:rPr>
-              <a:t>OCR → classification → VAT return → tax filing</a:t>
+              <a:t>34 deals · 2,400 staff · 65 offices · £100M+ rev</a:t>
             </a:r>
           </a:p>
         </p:txBody>
@@ -7203,7 +7203,7 @@
         <p:spPr>
           <a:xfrm>
             <a:off x="548640" y="3300984"/>
-            <a:ext cx="1280160" cy="274320"/>
+            <a:ext cx="1463040" cy="274320"/>
           </a:xfrm>
           <a:prstGeom prst="rect">
             <a:avLst/>
@@ -7218,13 +7218,13 @@
           <a:p>
             <a:pPr algn="l"/>
             <a:r>
-              <a:rPr sz="1050" b="1" i="0">
+              <a:rPr sz="1000" b="1" i="0">
                 <a:solidFill>
                   <a:srgbClr val="1F3A5F"/>
                 </a:solidFill>
                 <a:latin typeface="Calibri"/>
               </a:rPr>
-              <a:t>Automation:</a:t>
+              <a:t>Time to £100M rev:</a:t>
             </a:r>
           </a:p>
         </p:txBody>
@@ -7237,8 +7237,8 @@
         </p:nvSpPr>
         <p:spPr>
           <a:xfrm>
-            <a:off x="1828800" y="3300984"/>
-            <a:ext cx="3566160" cy="274320"/>
+            <a:off x="2011680" y="3300984"/>
+            <a:ext cx="3383280" cy="274320"/>
           </a:xfrm>
           <a:prstGeom prst="rect">
             <a:avLst/>
@@ -7253,13 +7253,13 @@
           <a:p>
             <a:pPr algn="l"/>
             <a:r>
-              <a:rPr sz="1050" b="0" i="0">
+              <a:rPr sz="1000" b="0" i="0">
                 <a:solidFill>
                   <a:srgbClr val="101010"/>
                 </a:solidFill>
                 <a:latin typeface="Calibri"/>
               </a:rPr>
-              <a:t>70–85% on routine entries</a:t>
+              <a:t>12 months from first close</a:t>
             </a:r>
           </a:p>
         </p:txBody>
@@ -7273,7 +7273,7 @@
         <p:spPr>
           <a:xfrm>
             <a:off x="548640" y="3593592"/>
-            <a:ext cx="1280160" cy="274320"/>
+            <a:ext cx="1463040" cy="274320"/>
           </a:xfrm>
           <a:prstGeom prst="rect">
             <a:avLst/>
@@ -7288,13 +7288,13 @@
           <a:p>
             <a:pPr algn="l"/>
             <a:r>
-              <a:rPr sz="1050" b="1" i="0">
+              <a:rPr sz="1000" b="1" i="0">
                 <a:solidFill>
                   <a:srgbClr val="1F3A5F"/>
                 </a:solidFill>
                 <a:latin typeface="Calibri"/>
               </a:rPr>
-              <a:t>Onboarding:</a:t>
+              <a:t>Model:</a:t>
             </a:r>
           </a:p>
         </p:txBody>
@@ -7307,8 +7307,8 @@
         </p:nvSpPr>
         <p:spPr>
           <a:xfrm>
-            <a:off x="1828800" y="3593592"/>
-            <a:ext cx="3566160" cy="274320"/>
+            <a:off x="2011680" y="3593592"/>
+            <a:ext cx="3383280" cy="274320"/>
           </a:xfrm>
           <a:prstGeom prst="rect">
             <a:avLst/>
@@ -7323,13 +7323,13 @@
           <a:p>
             <a:pPr algn="l"/>
             <a:r>
-              <a:rPr sz="1050" b="0" i="0">
+              <a:rPr sz="1000" b="0" i="0">
                 <a:solidFill>
                   <a:srgbClr val="101010"/>
                 </a:solidFill>
                 <a:latin typeface="Calibri"/>
               </a:rPr>
-              <a:t>15 minutes via bank feed + email forwarding</a:t>
+              <a:t>Majority stakes, retain local brand, centralize back-office</a:t>
             </a:r>
           </a:p>
         </p:txBody>
@@ -7343,7 +7343,7 @@
         <p:spPr>
           <a:xfrm>
             <a:off x="548640" y="3886200"/>
-            <a:ext cx="1280160" cy="274320"/>
+            <a:ext cx="1463040" cy="274320"/>
           </a:xfrm>
           <a:prstGeom prst="rect">
             <a:avLst/>
@@ -7358,13 +7358,13 @@
           <a:p>
             <a:pPr algn="l"/>
             <a:r>
-              <a:rPr sz="1050" b="1" i="0">
+              <a:rPr sz="1000" b="1" i="0">
                 <a:solidFill>
                   <a:srgbClr val="1F3A5F"/>
                 </a:solidFill>
                 <a:latin typeface="Calibri"/>
               </a:rPr>
-              <a:t>Validation:</a:t>
+              <a:t>Exit path:</a:t>
             </a:r>
           </a:p>
         </p:txBody>
@@ -7377,8 +7377,8 @@
         </p:nvSpPr>
         <p:spPr>
           <a:xfrm>
-            <a:off x="1828800" y="3886200"/>
-            <a:ext cx="3566160" cy="274320"/>
+            <a:off x="2011680" y="3886200"/>
+            <a:ext cx="3383280" cy="274320"/>
           </a:xfrm>
           <a:prstGeom prst="rect">
             <a:avLst/>
@@ -7393,13 +7393,13 @@
           <a:p>
             <a:pPr algn="l"/>
             <a:r>
-              <a:rPr sz="1050" b="0" i="0">
+              <a:rPr sz="1000" b="0" i="0">
                 <a:solidFill>
                   <a:srgbClr val="101010"/>
                 </a:solidFill>
                 <a:latin typeface="Calibri"/>
               </a:rPr>
-              <a:t>Holded acquired by Visma in 2021 (~€120M EV)</a:t>
+              <a:t>£700M–£1bn strategic review (Continuum, 2025)</a:t>
             </a:r>
           </a:p>
         </p:txBody>
@@ -7512,7 +7512,7 @@
                 </a:solidFill>
                 <a:latin typeface="Calibri"/>
               </a:rPr>
-              <a:t>We don't build Sumer. We acquire the labor base, layer Sumer-class automation on top.</a:t>
+              <a:t>36 months: zero → £700M+ valuation. We clone this playbook in PL/IT/CY with AI overlay as added kicker.</a:t>
             </a:r>
           </a:p>
         </p:txBody>

</xml_diff>